<commit_message>
test(pptx): measure the presented stage in regression checks
</commit_message>
<xml_diff>
--- a/e2e/pptx/fixtures/arrow-text-regressions.pptx
+++ b/e2e/pptx/fixtures/arrow-text-regressions.pptx
@@ -664,9 +664,29 @@
             <a:off x="762000" y="952500"/>
             <a:ext cx="1905000" cy="952500"/>
           </a:xfrm>
-          <a:prstGeom prst="rect">
+          <a:custGeom>
             <a:avLst/>
-          </a:prstGeom>
+            <a:gdLst/>
+            <a:ahLst/>
+            <a:cxnLst/>
+            <a:rect l="l" t="t" r="r" b="b"/>
+            <a:pathLst>
+              <a:path w="2000" h="1000">
+                <a:moveTo>
+                  <a:pt x="0" y="1000"/>
+                </a:moveTo>
+                <a:lnTo>
+                  <a:pt x="500" y="500"/>
+                </a:lnTo>
+                <a:lnTo>
+                  <a:pt x="1500" y="100"/>
+                </a:lnTo>
+                <a:lnTo>
+                  <a:pt x="2000" y="0"/>
+                </a:lnTo>
+              </a:path>
+            </a:pathLst>
+          </a:custGeom>
           <a:noFill/>
           <a:ln w="28575">
             <a:solidFill>

</xml_diff>

<commit_message>
test(pptx): regenerate e2e fixtures for starter layout placeholders
The generators build decks through PresentationBuilder, whose starter layouts now declare standard placeholders, so every generated deck's slide layouts change. Only ppt/slideLayouts/slideLayoutN.xml differs (360 parts across 36 decks); the Open XML SDK validator reports the same errors before and after.
</commit_message>
<xml_diff>
--- a/e2e/pptx/fixtures/arrow-text-regressions.pptx
+++ b/e2e/pptx/fixtures/arrow-text-regressions.pptx
@@ -46,6 +46,126 @@
           <a:chExt cx="0" cy="0"/>
         </a:xfrm>
       </p:grpSpPr>
+      <p:sp>
+        <p:nvSpPr>
+          <p:cNvPr id="2" name="CtrTitle Placeholder 1"/>
+          <p:cNvSpPr>
+            <a:spLocks noGrp="1"/>
+          </p:cNvSpPr>
+          <p:nvPr>
+            <p:ph type="ctrTitle" idx="0"/>
+          </p:nvPr>
+        </p:nvSpPr>
+        <p:spPr>
+          <a:xfrm>
+            <a:off x="975360" y="1645920"/>
+            <a:ext cx="10241280" cy="1508760"/>
+          </a:xfrm>
+        </p:spPr>
+        <p:txBody>
+          <a:bodyPr/>
+          <a:lstStyle/>
+          <a:p>
+            <a:endParaRPr lang="en-US"/>
+          </a:p>
+        </p:txBody>
+      </p:sp>
+      <p:sp>
+        <p:nvSpPr>
+          <p:cNvPr id="3" name="SubTitle Placeholder 2"/>
+          <p:cNvSpPr>
+            <a:spLocks noGrp="1"/>
+          </p:cNvSpPr>
+          <p:nvPr>
+            <p:ph type="subTitle" idx="1"/>
+          </p:nvPr>
+        </p:nvSpPr>
+        <p:spPr>
+          <a:xfrm>
+            <a:off x="1463040" y="3360420"/>
+            <a:ext cx="9265920" cy="1371600"/>
+          </a:xfrm>
+        </p:spPr>
+        <p:txBody>
+          <a:bodyPr/>
+          <a:lstStyle/>
+          <a:p>
+            <a:endParaRPr lang="en-US"/>
+          </a:p>
+        </p:txBody>
+      </p:sp>
+      <p:sp>
+        <p:nvSpPr>
+          <p:cNvPr id="4" name="Dt Placeholder 3"/>
+          <p:cNvSpPr>
+            <a:spLocks noGrp="1"/>
+          </p:cNvSpPr>
+          <p:nvPr>
+            <p:ph type="dt" idx="10"/>
+          </p:nvPr>
+        </p:nvSpPr>
+        <p:spPr>
+          <a:xfrm>
+            <a:off x="609600" y="6309360"/>
+            <a:ext cx="3048000" cy="274320"/>
+          </a:xfrm>
+        </p:spPr>
+        <p:txBody>
+          <a:bodyPr/>
+          <a:lstStyle/>
+          <a:p>
+            <a:endParaRPr lang="en-US"/>
+          </a:p>
+        </p:txBody>
+      </p:sp>
+      <p:sp>
+        <p:nvSpPr>
+          <p:cNvPr id="5" name="Ftr Placeholder 4"/>
+          <p:cNvSpPr>
+            <a:spLocks noGrp="1"/>
+          </p:cNvSpPr>
+          <p:nvPr>
+            <p:ph type="ftr" idx="11"/>
+          </p:nvPr>
+        </p:nvSpPr>
+        <p:spPr>
+          <a:xfrm>
+            <a:off x="4023360" y="6309360"/>
+            <a:ext cx="4145280" cy="274320"/>
+          </a:xfrm>
+        </p:spPr>
+        <p:txBody>
+          <a:bodyPr/>
+          <a:lstStyle/>
+          <a:p>
+            <a:endParaRPr lang="en-US"/>
+          </a:p>
+        </p:txBody>
+      </p:sp>
+      <p:sp>
+        <p:nvSpPr>
+          <p:cNvPr id="6" name="SldNum Placeholder 5"/>
+          <p:cNvSpPr>
+            <a:spLocks noGrp="1"/>
+          </p:cNvSpPr>
+          <p:nvPr>
+            <p:ph type="sldNum" idx="12"/>
+          </p:nvPr>
+        </p:nvSpPr>
+        <p:spPr>
+          <a:xfrm>
+            <a:off x="9144000" y="6309360"/>
+            <a:ext cx="2438400" cy="274320"/>
+          </a:xfrm>
+        </p:spPr>
+        <p:txBody>
+          <a:bodyPr/>
+          <a:lstStyle/>
+          <a:p>
+            <a:endParaRPr lang="en-US"/>
+          </a:p>
+        </p:txBody>
+      </p:sp>
     </p:spTree>
   </p:cSld>
   <p:clrMapOvr>
@@ -71,6 +191,126 @@
           <a:chExt cx="0" cy="0"/>
         </a:xfrm>
       </p:grpSpPr>
+      <p:sp>
+        <p:nvSpPr>
+          <p:cNvPr id="2" name="Title Placeholder 1"/>
+          <p:cNvSpPr>
+            <a:spLocks noGrp="1"/>
+          </p:cNvSpPr>
+          <p:nvPr>
+            <p:ph type="title" idx="0"/>
+          </p:nvPr>
+        </p:nvSpPr>
+        <p:spPr>
+          <a:xfrm>
+            <a:off x="609600" y="274320"/>
+            <a:ext cx="10972800" cy="1028700"/>
+          </a:xfrm>
+        </p:spPr>
+        <p:txBody>
+          <a:bodyPr/>
+          <a:lstStyle/>
+          <a:p>
+            <a:endParaRPr lang="en-US"/>
+          </a:p>
+        </p:txBody>
+      </p:sp>
+      <p:sp>
+        <p:nvSpPr>
+          <p:cNvPr id="3" name="Obj Placeholder 2"/>
+          <p:cNvSpPr>
+            <a:spLocks noGrp="1"/>
+          </p:cNvSpPr>
+          <p:nvPr>
+            <p:ph type="obj" idx="1"/>
+          </p:nvPr>
+        </p:nvSpPr>
+        <p:spPr>
+          <a:xfrm>
+            <a:off x="609600" y="1577340"/>
+            <a:ext cx="10972800" cy="4389120"/>
+          </a:xfrm>
+        </p:spPr>
+        <p:txBody>
+          <a:bodyPr/>
+          <a:lstStyle/>
+          <a:p>
+            <a:endParaRPr lang="en-US"/>
+          </a:p>
+        </p:txBody>
+      </p:sp>
+      <p:sp>
+        <p:nvSpPr>
+          <p:cNvPr id="4" name="Dt Placeholder 3"/>
+          <p:cNvSpPr>
+            <a:spLocks noGrp="1"/>
+          </p:cNvSpPr>
+          <p:nvPr>
+            <p:ph type="dt" idx="10"/>
+          </p:nvPr>
+        </p:nvSpPr>
+        <p:spPr>
+          <a:xfrm>
+            <a:off x="609600" y="6309360"/>
+            <a:ext cx="3048000" cy="274320"/>
+          </a:xfrm>
+        </p:spPr>
+        <p:txBody>
+          <a:bodyPr/>
+          <a:lstStyle/>
+          <a:p>
+            <a:endParaRPr lang="en-US"/>
+          </a:p>
+        </p:txBody>
+      </p:sp>
+      <p:sp>
+        <p:nvSpPr>
+          <p:cNvPr id="5" name="Ftr Placeholder 4"/>
+          <p:cNvSpPr>
+            <a:spLocks noGrp="1"/>
+          </p:cNvSpPr>
+          <p:nvPr>
+            <p:ph type="ftr" idx="11"/>
+          </p:nvPr>
+        </p:nvSpPr>
+        <p:spPr>
+          <a:xfrm>
+            <a:off x="4023360" y="6309360"/>
+            <a:ext cx="4145280" cy="274320"/>
+          </a:xfrm>
+        </p:spPr>
+        <p:txBody>
+          <a:bodyPr/>
+          <a:lstStyle/>
+          <a:p>
+            <a:endParaRPr lang="en-US"/>
+          </a:p>
+        </p:txBody>
+      </p:sp>
+      <p:sp>
+        <p:nvSpPr>
+          <p:cNvPr id="6" name="SldNum Placeholder 5"/>
+          <p:cNvSpPr>
+            <a:spLocks noGrp="1"/>
+          </p:cNvSpPr>
+          <p:nvPr>
+            <p:ph type="sldNum" idx="12"/>
+          </p:nvPr>
+        </p:nvSpPr>
+        <p:spPr>
+          <a:xfrm>
+            <a:off x="9144000" y="6309360"/>
+            <a:ext cx="2438400" cy="274320"/>
+          </a:xfrm>
+        </p:spPr>
+        <p:txBody>
+          <a:bodyPr/>
+          <a:lstStyle/>
+          <a:p>
+            <a:endParaRPr lang="en-US"/>
+          </a:p>
+        </p:txBody>
+      </p:sp>
     </p:spTree>
   </p:cSld>
   <p:clrMapOvr>
@@ -96,6 +336,126 @@
           <a:chExt cx="0" cy="0"/>
         </a:xfrm>
       </p:grpSpPr>
+      <p:sp>
+        <p:nvSpPr>
+          <p:cNvPr id="2" name="Title Placeholder 1"/>
+          <p:cNvSpPr>
+            <a:spLocks noGrp="1"/>
+          </p:cNvSpPr>
+          <p:nvPr>
+            <p:ph type="title" idx="0"/>
+          </p:nvPr>
+        </p:nvSpPr>
+        <p:spPr>
+          <a:xfrm>
+            <a:off x="609600" y="274320"/>
+            <a:ext cx="10972800" cy="1028700"/>
+          </a:xfrm>
+        </p:spPr>
+        <p:txBody>
+          <a:bodyPr/>
+          <a:lstStyle/>
+          <a:p>
+            <a:endParaRPr lang="en-US"/>
+          </a:p>
+        </p:txBody>
+      </p:sp>
+      <p:sp>
+        <p:nvSpPr>
+          <p:cNvPr id="3" name="Obj Placeholder 2"/>
+          <p:cNvSpPr>
+            <a:spLocks noGrp="1"/>
+          </p:cNvSpPr>
+          <p:nvPr>
+            <p:ph type="obj" idx="1"/>
+          </p:nvPr>
+        </p:nvSpPr>
+        <p:spPr>
+          <a:xfrm>
+            <a:off x="609600" y="1577340"/>
+            <a:ext cx="10972800" cy="4389120"/>
+          </a:xfrm>
+        </p:spPr>
+        <p:txBody>
+          <a:bodyPr/>
+          <a:lstStyle/>
+          <a:p>
+            <a:endParaRPr lang="en-US"/>
+          </a:p>
+        </p:txBody>
+      </p:sp>
+      <p:sp>
+        <p:nvSpPr>
+          <p:cNvPr id="4" name="Dt Placeholder 3"/>
+          <p:cNvSpPr>
+            <a:spLocks noGrp="1"/>
+          </p:cNvSpPr>
+          <p:nvPr>
+            <p:ph type="dt" idx="10"/>
+          </p:nvPr>
+        </p:nvSpPr>
+        <p:spPr>
+          <a:xfrm>
+            <a:off x="609600" y="6309360"/>
+            <a:ext cx="3048000" cy="274320"/>
+          </a:xfrm>
+        </p:spPr>
+        <p:txBody>
+          <a:bodyPr/>
+          <a:lstStyle/>
+          <a:p>
+            <a:endParaRPr lang="en-US"/>
+          </a:p>
+        </p:txBody>
+      </p:sp>
+      <p:sp>
+        <p:nvSpPr>
+          <p:cNvPr id="5" name="Ftr Placeholder 4"/>
+          <p:cNvSpPr>
+            <a:spLocks noGrp="1"/>
+          </p:cNvSpPr>
+          <p:nvPr>
+            <p:ph type="ftr" idx="11"/>
+          </p:nvPr>
+        </p:nvSpPr>
+        <p:spPr>
+          <a:xfrm>
+            <a:off x="4023360" y="6309360"/>
+            <a:ext cx="4145280" cy="274320"/>
+          </a:xfrm>
+        </p:spPr>
+        <p:txBody>
+          <a:bodyPr/>
+          <a:lstStyle/>
+          <a:p>
+            <a:endParaRPr lang="en-US"/>
+          </a:p>
+        </p:txBody>
+      </p:sp>
+      <p:sp>
+        <p:nvSpPr>
+          <p:cNvPr id="6" name="SldNum Placeholder 5"/>
+          <p:cNvSpPr>
+            <a:spLocks noGrp="1"/>
+          </p:cNvSpPr>
+          <p:nvPr>
+            <p:ph type="sldNum" idx="12"/>
+          </p:nvPr>
+        </p:nvSpPr>
+        <p:spPr>
+          <a:xfrm>
+            <a:off x="9144000" y="6309360"/>
+            <a:ext cx="2438400" cy="274320"/>
+          </a:xfrm>
+        </p:spPr>
+        <p:txBody>
+          <a:bodyPr/>
+          <a:lstStyle/>
+          <a:p>
+            <a:endParaRPr lang="en-US"/>
+          </a:p>
+        </p:txBody>
+      </p:sp>
     </p:spTree>
   </p:cSld>
   <p:clrMapOvr>
@@ -121,6 +481,126 @@
           <a:chExt cx="0" cy="0"/>
         </a:xfrm>
       </p:grpSpPr>
+      <p:sp>
+        <p:nvSpPr>
+          <p:cNvPr id="2" name="Title Placeholder 1"/>
+          <p:cNvSpPr>
+            <a:spLocks noGrp="1"/>
+          </p:cNvSpPr>
+          <p:nvPr>
+            <p:ph type="title" idx="0"/>
+          </p:nvPr>
+        </p:nvSpPr>
+        <p:spPr>
+          <a:xfrm>
+            <a:off x="609600" y="274320"/>
+            <a:ext cx="10972800" cy="1028700"/>
+          </a:xfrm>
+        </p:spPr>
+        <p:txBody>
+          <a:bodyPr/>
+          <a:lstStyle/>
+          <a:p>
+            <a:endParaRPr lang="en-US"/>
+          </a:p>
+        </p:txBody>
+      </p:sp>
+      <p:sp>
+        <p:nvSpPr>
+          <p:cNvPr id="3" name="Obj Placeholder 2"/>
+          <p:cNvSpPr>
+            <a:spLocks noGrp="1"/>
+          </p:cNvSpPr>
+          <p:nvPr>
+            <p:ph type="obj" idx="1"/>
+          </p:nvPr>
+        </p:nvSpPr>
+        <p:spPr>
+          <a:xfrm>
+            <a:off x="609600" y="1577340"/>
+            <a:ext cx="10972800" cy="4389120"/>
+          </a:xfrm>
+        </p:spPr>
+        <p:txBody>
+          <a:bodyPr/>
+          <a:lstStyle/>
+          <a:p>
+            <a:endParaRPr lang="en-US"/>
+          </a:p>
+        </p:txBody>
+      </p:sp>
+      <p:sp>
+        <p:nvSpPr>
+          <p:cNvPr id="4" name="Dt Placeholder 3"/>
+          <p:cNvSpPr>
+            <a:spLocks noGrp="1"/>
+          </p:cNvSpPr>
+          <p:nvPr>
+            <p:ph type="dt" idx="10"/>
+          </p:nvPr>
+        </p:nvSpPr>
+        <p:spPr>
+          <a:xfrm>
+            <a:off x="609600" y="6309360"/>
+            <a:ext cx="3048000" cy="274320"/>
+          </a:xfrm>
+        </p:spPr>
+        <p:txBody>
+          <a:bodyPr/>
+          <a:lstStyle/>
+          <a:p>
+            <a:endParaRPr lang="en-US"/>
+          </a:p>
+        </p:txBody>
+      </p:sp>
+      <p:sp>
+        <p:nvSpPr>
+          <p:cNvPr id="5" name="Ftr Placeholder 4"/>
+          <p:cNvSpPr>
+            <a:spLocks noGrp="1"/>
+          </p:cNvSpPr>
+          <p:nvPr>
+            <p:ph type="ftr" idx="11"/>
+          </p:nvPr>
+        </p:nvSpPr>
+        <p:spPr>
+          <a:xfrm>
+            <a:off x="4023360" y="6309360"/>
+            <a:ext cx="4145280" cy="274320"/>
+          </a:xfrm>
+        </p:spPr>
+        <p:txBody>
+          <a:bodyPr/>
+          <a:lstStyle/>
+          <a:p>
+            <a:endParaRPr lang="en-US"/>
+          </a:p>
+        </p:txBody>
+      </p:sp>
+      <p:sp>
+        <p:nvSpPr>
+          <p:cNvPr id="6" name="SldNum Placeholder 5"/>
+          <p:cNvSpPr>
+            <a:spLocks noGrp="1"/>
+          </p:cNvSpPr>
+          <p:nvPr>
+            <p:ph type="sldNum" idx="12"/>
+          </p:nvPr>
+        </p:nvSpPr>
+        <p:spPr>
+          <a:xfrm>
+            <a:off x="9144000" y="6309360"/>
+            <a:ext cx="2438400" cy="274320"/>
+          </a:xfrm>
+        </p:spPr>
+        <p:txBody>
+          <a:bodyPr/>
+          <a:lstStyle/>
+          <a:p>
+            <a:endParaRPr lang="en-US"/>
+          </a:p>
+        </p:txBody>
+      </p:sp>
     </p:spTree>
   </p:cSld>
   <p:clrMapOvr>
@@ -146,6 +626,126 @@
           <a:chExt cx="0" cy="0"/>
         </a:xfrm>
       </p:grpSpPr>
+      <p:sp>
+        <p:nvSpPr>
+          <p:cNvPr id="2" name="Title Placeholder 1"/>
+          <p:cNvSpPr>
+            <a:spLocks noGrp="1"/>
+          </p:cNvSpPr>
+          <p:nvPr>
+            <p:ph type="title" idx="0"/>
+          </p:nvPr>
+        </p:nvSpPr>
+        <p:spPr>
+          <a:xfrm>
+            <a:off x="609600" y="2537460"/>
+            <a:ext cx="10972800" cy="1371600"/>
+          </a:xfrm>
+        </p:spPr>
+        <p:txBody>
+          <a:bodyPr/>
+          <a:lstStyle/>
+          <a:p>
+            <a:endParaRPr lang="en-US"/>
+          </a:p>
+        </p:txBody>
+      </p:sp>
+      <p:sp>
+        <p:nvSpPr>
+          <p:cNvPr id="3" name="Body Placeholder 2"/>
+          <p:cNvSpPr>
+            <a:spLocks noGrp="1"/>
+          </p:cNvSpPr>
+          <p:nvPr>
+            <p:ph type="body" idx="1"/>
+          </p:nvPr>
+        </p:nvSpPr>
+        <p:spPr>
+          <a:xfrm>
+            <a:off x="609600" y="4114800"/>
+            <a:ext cx="10972800" cy="1577340"/>
+          </a:xfrm>
+        </p:spPr>
+        <p:txBody>
+          <a:bodyPr/>
+          <a:lstStyle/>
+          <a:p>
+            <a:endParaRPr lang="en-US"/>
+          </a:p>
+        </p:txBody>
+      </p:sp>
+      <p:sp>
+        <p:nvSpPr>
+          <p:cNvPr id="4" name="Dt Placeholder 3"/>
+          <p:cNvSpPr>
+            <a:spLocks noGrp="1"/>
+          </p:cNvSpPr>
+          <p:nvPr>
+            <p:ph type="dt" idx="10"/>
+          </p:nvPr>
+        </p:nvSpPr>
+        <p:spPr>
+          <a:xfrm>
+            <a:off x="609600" y="6309360"/>
+            <a:ext cx="3048000" cy="274320"/>
+          </a:xfrm>
+        </p:spPr>
+        <p:txBody>
+          <a:bodyPr/>
+          <a:lstStyle/>
+          <a:p>
+            <a:endParaRPr lang="en-US"/>
+          </a:p>
+        </p:txBody>
+      </p:sp>
+      <p:sp>
+        <p:nvSpPr>
+          <p:cNvPr id="5" name="Ftr Placeholder 4"/>
+          <p:cNvSpPr>
+            <a:spLocks noGrp="1"/>
+          </p:cNvSpPr>
+          <p:nvPr>
+            <p:ph type="ftr" idx="11"/>
+          </p:nvPr>
+        </p:nvSpPr>
+        <p:spPr>
+          <a:xfrm>
+            <a:off x="4023360" y="6309360"/>
+            <a:ext cx="4145280" cy="274320"/>
+          </a:xfrm>
+        </p:spPr>
+        <p:txBody>
+          <a:bodyPr/>
+          <a:lstStyle/>
+          <a:p>
+            <a:endParaRPr lang="en-US"/>
+          </a:p>
+        </p:txBody>
+      </p:sp>
+      <p:sp>
+        <p:nvSpPr>
+          <p:cNvPr id="6" name="SldNum Placeholder 5"/>
+          <p:cNvSpPr>
+            <a:spLocks noGrp="1"/>
+          </p:cNvSpPr>
+          <p:nvPr>
+            <p:ph type="sldNum" idx="12"/>
+          </p:nvPr>
+        </p:nvSpPr>
+        <p:spPr>
+          <a:xfrm>
+            <a:off x="9144000" y="6309360"/>
+            <a:ext cx="2438400" cy="274320"/>
+          </a:xfrm>
+        </p:spPr>
+        <p:txBody>
+          <a:bodyPr/>
+          <a:lstStyle/>
+          <a:p>
+            <a:endParaRPr lang="en-US"/>
+          </a:p>
+        </p:txBody>
+      </p:sp>
     </p:spTree>
   </p:cSld>
   <p:clrMapOvr>
@@ -171,6 +771,150 @@
           <a:chExt cx="0" cy="0"/>
         </a:xfrm>
       </p:grpSpPr>
+      <p:sp>
+        <p:nvSpPr>
+          <p:cNvPr id="2" name="Title Placeholder 1"/>
+          <p:cNvSpPr>
+            <a:spLocks noGrp="1"/>
+          </p:cNvSpPr>
+          <p:nvPr>
+            <p:ph type="title" idx="0"/>
+          </p:nvPr>
+        </p:nvSpPr>
+        <p:spPr>
+          <a:xfrm>
+            <a:off x="609600" y="274320"/>
+            <a:ext cx="10972800" cy="1028700"/>
+          </a:xfrm>
+        </p:spPr>
+        <p:txBody>
+          <a:bodyPr/>
+          <a:lstStyle/>
+          <a:p>
+            <a:endParaRPr lang="en-US"/>
+          </a:p>
+        </p:txBody>
+      </p:sp>
+      <p:sp>
+        <p:nvSpPr>
+          <p:cNvPr id="3" name="Obj Placeholder 2"/>
+          <p:cNvSpPr>
+            <a:spLocks noGrp="1"/>
+          </p:cNvSpPr>
+          <p:nvPr>
+            <p:ph type="obj" idx="1"/>
+          </p:nvPr>
+        </p:nvSpPr>
+        <p:spPr>
+          <a:xfrm>
+            <a:off x="609600" y="1851660"/>
+            <a:ext cx="5242560" cy="4114800"/>
+          </a:xfrm>
+        </p:spPr>
+        <p:txBody>
+          <a:bodyPr/>
+          <a:lstStyle/>
+          <a:p>
+            <a:endParaRPr lang="en-US"/>
+          </a:p>
+        </p:txBody>
+      </p:sp>
+      <p:sp>
+        <p:nvSpPr>
+          <p:cNvPr id="4" name="Obj Placeholder 3"/>
+          <p:cNvSpPr>
+            <a:spLocks noGrp="1"/>
+          </p:cNvSpPr>
+          <p:nvPr>
+            <p:ph type="obj" idx="2"/>
+          </p:nvPr>
+        </p:nvSpPr>
+        <p:spPr>
+          <a:xfrm>
+            <a:off x="6339840" y="1851660"/>
+            <a:ext cx="5242560" cy="4114800"/>
+          </a:xfrm>
+        </p:spPr>
+        <p:txBody>
+          <a:bodyPr/>
+          <a:lstStyle/>
+          <a:p>
+            <a:endParaRPr lang="en-US"/>
+          </a:p>
+        </p:txBody>
+      </p:sp>
+      <p:sp>
+        <p:nvSpPr>
+          <p:cNvPr id="5" name="Dt Placeholder 4"/>
+          <p:cNvSpPr>
+            <a:spLocks noGrp="1"/>
+          </p:cNvSpPr>
+          <p:nvPr>
+            <p:ph type="dt" idx="10"/>
+          </p:nvPr>
+        </p:nvSpPr>
+        <p:spPr>
+          <a:xfrm>
+            <a:off x="609600" y="6309360"/>
+            <a:ext cx="3048000" cy="274320"/>
+          </a:xfrm>
+        </p:spPr>
+        <p:txBody>
+          <a:bodyPr/>
+          <a:lstStyle/>
+          <a:p>
+            <a:endParaRPr lang="en-US"/>
+          </a:p>
+        </p:txBody>
+      </p:sp>
+      <p:sp>
+        <p:nvSpPr>
+          <p:cNvPr id="6" name="Ftr Placeholder 5"/>
+          <p:cNvSpPr>
+            <a:spLocks noGrp="1"/>
+          </p:cNvSpPr>
+          <p:nvPr>
+            <p:ph type="ftr" idx="11"/>
+          </p:nvPr>
+        </p:nvSpPr>
+        <p:spPr>
+          <a:xfrm>
+            <a:off x="4023360" y="6309360"/>
+            <a:ext cx="4145280" cy="274320"/>
+          </a:xfrm>
+        </p:spPr>
+        <p:txBody>
+          <a:bodyPr/>
+          <a:lstStyle/>
+          <a:p>
+            <a:endParaRPr lang="en-US"/>
+          </a:p>
+        </p:txBody>
+      </p:sp>
+      <p:sp>
+        <p:nvSpPr>
+          <p:cNvPr id="7" name="SldNum Placeholder 6"/>
+          <p:cNvSpPr>
+            <a:spLocks noGrp="1"/>
+          </p:cNvSpPr>
+          <p:nvPr>
+            <p:ph type="sldNum" idx="12"/>
+          </p:nvPr>
+        </p:nvSpPr>
+        <p:spPr>
+          <a:xfrm>
+            <a:off x="9144000" y="6309360"/>
+            <a:ext cx="2438400" cy="274320"/>
+          </a:xfrm>
+        </p:spPr>
+        <p:txBody>
+          <a:bodyPr/>
+          <a:lstStyle/>
+          <a:p>
+            <a:endParaRPr lang="en-US"/>
+          </a:p>
+        </p:txBody>
+      </p:sp>
     </p:spTree>
   </p:cSld>
   <p:clrMapOvr>
@@ -196,6 +940,198 @@
           <a:chExt cx="0" cy="0"/>
         </a:xfrm>
       </p:grpSpPr>
+      <p:sp>
+        <p:nvSpPr>
+          <p:cNvPr id="2" name="Title Placeholder 1"/>
+          <p:cNvSpPr>
+            <a:spLocks noGrp="1"/>
+          </p:cNvSpPr>
+          <p:nvPr>
+            <p:ph type="title" idx="0"/>
+          </p:nvPr>
+        </p:nvSpPr>
+        <p:spPr>
+          <a:xfrm>
+            <a:off x="609600" y="274320"/>
+            <a:ext cx="10972800" cy="1028700"/>
+          </a:xfrm>
+        </p:spPr>
+        <p:txBody>
+          <a:bodyPr/>
+          <a:lstStyle/>
+          <a:p>
+            <a:endParaRPr lang="en-US"/>
+          </a:p>
+        </p:txBody>
+      </p:sp>
+      <p:sp>
+        <p:nvSpPr>
+          <p:cNvPr id="3" name="Obj Placeholder 2"/>
+          <p:cNvSpPr>
+            <a:spLocks noGrp="1"/>
+          </p:cNvSpPr>
+          <p:nvPr>
+            <p:ph type="obj" idx="1"/>
+          </p:nvPr>
+        </p:nvSpPr>
+        <p:spPr>
+          <a:xfrm>
+            <a:off x="609600" y="1851660"/>
+            <a:ext cx="5242560" cy="4114800"/>
+          </a:xfrm>
+        </p:spPr>
+        <p:txBody>
+          <a:bodyPr/>
+          <a:lstStyle/>
+          <a:p>
+            <a:endParaRPr lang="en-US"/>
+          </a:p>
+        </p:txBody>
+      </p:sp>
+      <p:sp>
+        <p:nvSpPr>
+          <p:cNvPr id="4" name="Obj Placeholder 3"/>
+          <p:cNvSpPr>
+            <a:spLocks noGrp="1"/>
+          </p:cNvSpPr>
+          <p:nvPr>
+            <p:ph type="obj" idx="2"/>
+          </p:nvPr>
+        </p:nvSpPr>
+        <p:spPr>
+          <a:xfrm>
+            <a:off x="6339840" y="1851660"/>
+            <a:ext cx="5242560" cy="4114800"/>
+          </a:xfrm>
+        </p:spPr>
+        <p:txBody>
+          <a:bodyPr/>
+          <a:lstStyle/>
+          <a:p>
+            <a:endParaRPr lang="en-US"/>
+          </a:p>
+        </p:txBody>
+      </p:sp>
+      <p:sp>
+        <p:nvSpPr>
+          <p:cNvPr id="5" name="Body Placeholder 4"/>
+          <p:cNvSpPr>
+            <a:spLocks noGrp="1"/>
+          </p:cNvSpPr>
+          <p:nvPr>
+            <p:ph type="body" idx="3"/>
+          </p:nvPr>
+        </p:nvSpPr>
+        <p:spPr>
+          <a:xfrm>
+            <a:off x="609600" y="1371600"/>
+            <a:ext cx="5242560" cy="480060"/>
+          </a:xfrm>
+        </p:spPr>
+        <p:txBody>
+          <a:bodyPr/>
+          <a:lstStyle/>
+          <a:p>
+            <a:endParaRPr lang="en-US"/>
+          </a:p>
+        </p:txBody>
+      </p:sp>
+      <p:sp>
+        <p:nvSpPr>
+          <p:cNvPr id="6" name="Body Placeholder 5"/>
+          <p:cNvSpPr>
+            <a:spLocks noGrp="1"/>
+          </p:cNvSpPr>
+          <p:nvPr>
+            <p:ph type="body" idx="4"/>
+          </p:nvPr>
+        </p:nvSpPr>
+        <p:spPr>
+          <a:xfrm>
+            <a:off x="6339840" y="1371600"/>
+            <a:ext cx="5242560" cy="480060"/>
+          </a:xfrm>
+        </p:spPr>
+        <p:txBody>
+          <a:bodyPr/>
+          <a:lstStyle/>
+          <a:p>
+            <a:endParaRPr lang="en-US"/>
+          </a:p>
+        </p:txBody>
+      </p:sp>
+      <p:sp>
+        <p:nvSpPr>
+          <p:cNvPr id="7" name="Dt Placeholder 6"/>
+          <p:cNvSpPr>
+            <a:spLocks noGrp="1"/>
+          </p:cNvSpPr>
+          <p:nvPr>
+            <p:ph type="dt" idx="10"/>
+          </p:nvPr>
+        </p:nvSpPr>
+        <p:spPr>
+          <a:xfrm>
+            <a:off x="609600" y="6309360"/>
+            <a:ext cx="3048000" cy="274320"/>
+          </a:xfrm>
+        </p:spPr>
+        <p:txBody>
+          <a:bodyPr/>
+          <a:lstStyle/>
+          <a:p>
+            <a:endParaRPr lang="en-US"/>
+          </a:p>
+        </p:txBody>
+      </p:sp>
+      <p:sp>
+        <p:nvSpPr>
+          <p:cNvPr id="8" name="Ftr Placeholder 7"/>
+          <p:cNvSpPr>
+            <a:spLocks noGrp="1"/>
+          </p:cNvSpPr>
+          <p:nvPr>
+            <p:ph type="ftr" idx="11"/>
+          </p:nvPr>
+        </p:nvSpPr>
+        <p:spPr>
+          <a:xfrm>
+            <a:off x="4023360" y="6309360"/>
+            <a:ext cx="4145280" cy="274320"/>
+          </a:xfrm>
+        </p:spPr>
+        <p:txBody>
+          <a:bodyPr/>
+          <a:lstStyle/>
+          <a:p>
+            <a:endParaRPr lang="en-US"/>
+          </a:p>
+        </p:txBody>
+      </p:sp>
+      <p:sp>
+        <p:nvSpPr>
+          <p:cNvPr id="9" name="SldNum Placeholder 8"/>
+          <p:cNvSpPr>
+            <a:spLocks noGrp="1"/>
+          </p:cNvSpPr>
+          <p:nvPr>
+            <p:ph type="sldNum" idx="12"/>
+          </p:nvPr>
+        </p:nvSpPr>
+        <p:spPr>
+          <a:xfrm>
+            <a:off x="9144000" y="6309360"/>
+            <a:ext cx="2438400" cy="274320"/>
+          </a:xfrm>
+        </p:spPr>
+        <p:txBody>
+          <a:bodyPr/>
+          <a:lstStyle/>
+          <a:p>
+            <a:endParaRPr lang="en-US"/>
+          </a:p>
+        </p:txBody>
+      </p:sp>
     </p:spTree>
   </p:cSld>
   <p:clrMapOvr>
@@ -221,6 +1157,102 @@
           <a:chExt cx="0" cy="0"/>
         </a:xfrm>
       </p:grpSpPr>
+      <p:sp>
+        <p:nvSpPr>
+          <p:cNvPr id="2" name="Title Placeholder 1"/>
+          <p:cNvSpPr>
+            <a:spLocks noGrp="1"/>
+          </p:cNvSpPr>
+          <p:nvPr>
+            <p:ph type="title" idx="0"/>
+          </p:nvPr>
+        </p:nvSpPr>
+        <p:spPr>
+          <a:xfrm>
+            <a:off x="609600" y="274320"/>
+            <a:ext cx="10972800" cy="1028700"/>
+          </a:xfrm>
+        </p:spPr>
+        <p:txBody>
+          <a:bodyPr/>
+          <a:lstStyle/>
+          <a:p>
+            <a:endParaRPr lang="en-US"/>
+          </a:p>
+        </p:txBody>
+      </p:sp>
+      <p:sp>
+        <p:nvSpPr>
+          <p:cNvPr id="3" name="Dt Placeholder 2"/>
+          <p:cNvSpPr>
+            <a:spLocks noGrp="1"/>
+          </p:cNvSpPr>
+          <p:nvPr>
+            <p:ph type="dt" idx="10"/>
+          </p:nvPr>
+        </p:nvSpPr>
+        <p:spPr>
+          <a:xfrm>
+            <a:off x="609600" y="6309360"/>
+            <a:ext cx="3048000" cy="274320"/>
+          </a:xfrm>
+        </p:spPr>
+        <p:txBody>
+          <a:bodyPr/>
+          <a:lstStyle/>
+          <a:p>
+            <a:endParaRPr lang="en-US"/>
+          </a:p>
+        </p:txBody>
+      </p:sp>
+      <p:sp>
+        <p:nvSpPr>
+          <p:cNvPr id="4" name="Ftr Placeholder 3"/>
+          <p:cNvSpPr>
+            <a:spLocks noGrp="1"/>
+          </p:cNvSpPr>
+          <p:nvPr>
+            <p:ph type="ftr" idx="11"/>
+          </p:nvPr>
+        </p:nvSpPr>
+        <p:spPr>
+          <a:xfrm>
+            <a:off x="4023360" y="6309360"/>
+            <a:ext cx="4145280" cy="274320"/>
+          </a:xfrm>
+        </p:spPr>
+        <p:txBody>
+          <a:bodyPr/>
+          <a:lstStyle/>
+          <a:p>
+            <a:endParaRPr lang="en-US"/>
+          </a:p>
+        </p:txBody>
+      </p:sp>
+      <p:sp>
+        <p:nvSpPr>
+          <p:cNvPr id="5" name="SldNum Placeholder 4"/>
+          <p:cNvSpPr>
+            <a:spLocks noGrp="1"/>
+          </p:cNvSpPr>
+          <p:nvPr>
+            <p:ph type="sldNum" idx="12"/>
+          </p:nvPr>
+        </p:nvSpPr>
+        <p:spPr>
+          <a:xfrm>
+            <a:off x="9144000" y="6309360"/>
+            <a:ext cx="2438400" cy="274320"/>
+          </a:xfrm>
+        </p:spPr>
+        <p:txBody>
+          <a:bodyPr/>
+          <a:lstStyle/>
+          <a:p>
+            <a:endParaRPr lang="en-US"/>
+          </a:p>
+        </p:txBody>
+      </p:sp>
     </p:spTree>
   </p:cSld>
   <p:clrMapOvr>
@@ -271,6 +1303,150 @@
           <a:chExt cx="0" cy="0"/>
         </a:xfrm>
       </p:grpSpPr>
+      <p:sp>
+        <p:nvSpPr>
+          <p:cNvPr id="2" name="Title Placeholder 1"/>
+          <p:cNvSpPr>
+            <a:spLocks noGrp="1"/>
+          </p:cNvSpPr>
+          <p:nvPr>
+            <p:ph type="title" idx="0"/>
+          </p:nvPr>
+        </p:nvSpPr>
+        <p:spPr>
+          <a:xfrm>
+            <a:off x="609600" y="274320"/>
+            <a:ext cx="10972800" cy="1028700"/>
+          </a:xfrm>
+        </p:spPr>
+        <p:txBody>
+          <a:bodyPr/>
+          <a:lstStyle/>
+          <a:p>
+            <a:endParaRPr lang="en-US"/>
+          </a:p>
+        </p:txBody>
+      </p:sp>
+      <p:sp>
+        <p:nvSpPr>
+          <p:cNvPr id="3" name="Obj Placeholder 2"/>
+          <p:cNvSpPr>
+            <a:spLocks noGrp="1"/>
+          </p:cNvSpPr>
+          <p:nvPr>
+            <p:ph type="obj" idx="1"/>
+          </p:nvPr>
+        </p:nvSpPr>
+        <p:spPr>
+          <a:xfrm>
+            <a:off x="4389120" y="1577340"/>
+            <a:ext cx="7193280" cy="4389120"/>
+          </a:xfrm>
+        </p:spPr>
+        <p:txBody>
+          <a:bodyPr/>
+          <a:lstStyle/>
+          <a:p>
+            <a:endParaRPr lang="en-US"/>
+          </a:p>
+        </p:txBody>
+      </p:sp>
+      <p:sp>
+        <p:nvSpPr>
+          <p:cNvPr id="4" name="Body Placeholder 3"/>
+          <p:cNvSpPr>
+            <a:spLocks noGrp="1"/>
+          </p:cNvSpPr>
+          <p:nvPr>
+            <p:ph type="body" idx="2"/>
+          </p:nvPr>
+        </p:nvSpPr>
+        <p:spPr>
+          <a:xfrm>
+            <a:off x="609600" y="1577340"/>
+            <a:ext cx="3291840" cy="4389120"/>
+          </a:xfrm>
+        </p:spPr>
+        <p:txBody>
+          <a:bodyPr/>
+          <a:lstStyle/>
+          <a:p>
+            <a:endParaRPr lang="en-US"/>
+          </a:p>
+        </p:txBody>
+      </p:sp>
+      <p:sp>
+        <p:nvSpPr>
+          <p:cNvPr id="5" name="Dt Placeholder 4"/>
+          <p:cNvSpPr>
+            <a:spLocks noGrp="1"/>
+          </p:cNvSpPr>
+          <p:nvPr>
+            <p:ph type="dt" idx="10"/>
+          </p:nvPr>
+        </p:nvSpPr>
+        <p:spPr>
+          <a:xfrm>
+            <a:off x="609600" y="6309360"/>
+            <a:ext cx="3048000" cy="274320"/>
+          </a:xfrm>
+        </p:spPr>
+        <p:txBody>
+          <a:bodyPr/>
+          <a:lstStyle/>
+          <a:p>
+            <a:endParaRPr lang="en-US"/>
+          </a:p>
+        </p:txBody>
+      </p:sp>
+      <p:sp>
+        <p:nvSpPr>
+          <p:cNvPr id="6" name="Ftr Placeholder 5"/>
+          <p:cNvSpPr>
+            <a:spLocks noGrp="1"/>
+          </p:cNvSpPr>
+          <p:nvPr>
+            <p:ph type="ftr" idx="11"/>
+          </p:nvPr>
+        </p:nvSpPr>
+        <p:spPr>
+          <a:xfrm>
+            <a:off x="4023360" y="6309360"/>
+            <a:ext cx="4145280" cy="274320"/>
+          </a:xfrm>
+        </p:spPr>
+        <p:txBody>
+          <a:bodyPr/>
+          <a:lstStyle/>
+          <a:p>
+            <a:endParaRPr lang="en-US"/>
+          </a:p>
+        </p:txBody>
+      </p:sp>
+      <p:sp>
+        <p:nvSpPr>
+          <p:cNvPr id="7" name="SldNum Placeholder 6"/>
+          <p:cNvSpPr>
+            <a:spLocks noGrp="1"/>
+          </p:cNvSpPr>
+          <p:nvPr>
+            <p:ph type="sldNum" idx="12"/>
+          </p:nvPr>
+        </p:nvSpPr>
+        <p:spPr>
+          <a:xfrm>
+            <a:off x="9144000" y="6309360"/>
+            <a:ext cx="2438400" cy="274320"/>
+          </a:xfrm>
+        </p:spPr>
+        <p:txBody>
+          <a:bodyPr/>
+          <a:lstStyle/>
+          <a:p>
+            <a:endParaRPr lang="en-US"/>
+          </a:p>
+        </p:txBody>
+      </p:sp>
     </p:spTree>
   </p:cSld>
   <p:clrMapOvr>
@@ -296,6 +1472,150 @@
           <a:chExt cx="0" cy="0"/>
         </a:xfrm>
       </p:grpSpPr>
+      <p:sp>
+        <p:nvSpPr>
+          <p:cNvPr id="2" name="Title Placeholder 1"/>
+          <p:cNvSpPr>
+            <a:spLocks noGrp="1"/>
+          </p:cNvSpPr>
+          <p:nvPr>
+            <p:ph type="title" idx="0"/>
+          </p:nvPr>
+        </p:nvSpPr>
+        <p:spPr>
+          <a:xfrm>
+            <a:off x="609600" y="274320"/>
+            <a:ext cx="10972800" cy="1028700"/>
+          </a:xfrm>
+        </p:spPr>
+        <p:txBody>
+          <a:bodyPr/>
+          <a:lstStyle/>
+          <a:p>
+            <a:endParaRPr lang="en-US"/>
+          </a:p>
+        </p:txBody>
+      </p:sp>
+      <p:sp>
+        <p:nvSpPr>
+          <p:cNvPr id="3" name="Pic Placeholder 2"/>
+          <p:cNvSpPr>
+            <a:spLocks noGrp="1"/>
+          </p:cNvSpPr>
+          <p:nvPr>
+            <p:ph type="pic" idx="1"/>
+          </p:nvPr>
+        </p:nvSpPr>
+        <p:spPr>
+          <a:xfrm>
+            <a:off x="4389120" y="1577340"/>
+            <a:ext cx="7193280" cy="4389120"/>
+          </a:xfrm>
+        </p:spPr>
+        <p:txBody>
+          <a:bodyPr/>
+          <a:lstStyle/>
+          <a:p>
+            <a:endParaRPr lang="en-US"/>
+          </a:p>
+        </p:txBody>
+      </p:sp>
+      <p:sp>
+        <p:nvSpPr>
+          <p:cNvPr id="4" name="Body Placeholder 3"/>
+          <p:cNvSpPr>
+            <a:spLocks noGrp="1"/>
+          </p:cNvSpPr>
+          <p:nvPr>
+            <p:ph type="body" idx="2"/>
+          </p:nvPr>
+        </p:nvSpPr>
+        <p:spPr>
+          <a:xfrm>
+            <a:off x="609600" y="1577340"/>
+            <a:ext cx="3291840" cy="4389120"/>
+          </a:xfrm>
+        </p:spPr>
+        <p:txBody>
+          <a:bodyPr/>
+          <a:lstStyle/>
+          <a:p>
+            <a:endParaRPr lang="en-US"/>
+          </a:p>
+        </p:txBody>
+      </p:sp>
+      <p:sp>
+        <p:nvSpPr>
+          <p:cNvPr id="5" name="Dt Placeholder 4"/>
+          <p:cNvSpPr>
+            <a:spLocks noGrp="1"/>
+          </p:cNvSpPr>
+          <p:nvPr>
+            <p:ph type="dt" idx="10"/>
+          </p:nvPr>
+        </p:nvSpPr>
+        <p:spPr>
+          <a:xfrm>
+            <a:off x="609600" y="6309360"/>
+            <a:ext cx="3048000" cy="274320"/>
+          </a:xfrm>
+        </p:spPr>
+        <p:txBody>
+          <a:bodyPr/>
+          <a:lstStyle/>
+          <a:p>
+            <a:endParaRPr lang="en-US"/>
+          </a:p>
+        </p:txBody>
+      </p:sp>
+      <p:sp>
+        <p:nvSpPr>
+          <p:cNvPr id="6" name="Ftr Placeholder 5"/>
+          <p:cNvSpPr>
+            <a:spLocks noGrp="1"/>
+          </p:cNvSpPr>
+          <p:nvPr>
+            <p:ph type="ftr" idx="11"/>
+          </p:nvPr>
+        </p:nvSpPr>
+        <p:spPr>
+          <a:xfrm>
+            <a:off x="4023360" y="6309360"/>
+            <a:ext cx="4145280" cy="274320"/>
+          </a:xfrm>
+        </p:spPr>
+        <p:txBody>
+          <a:bodyPr/>
+          <a:lstStyle/>
+          <a:p>
+            <a:endParaRPr lang="en-US"/>
+          </a:p>
+        </p:txBody>
+      </p:sp>
+      <p:sp>
+        <p:nvSpPr>
+          <p:cNvPr id="7" name="SldNum Placeholder 6"/>
+          <p:cNvSpPr>
+            <a:spLocks noGrp="1"/>
+          </p:cNvSpPr>
+          <p:nvPr>
+            <p:ph type="sldNum" idx="12"/>
+          </p:nvPr>
+        </p:nvSpPr>
+        <p:spPr>
+          <a:xfrm>
+            <a:off x="9144000" y="6309360"/>
+            <a:ext cx="2438400" cy="274320"/>
+          </a:xfrm>
+        </p:spPr>
+        <p:txBody>
+          <a:bodyPr/>
+          <a:lstStyle/>
+          <a:p>
+            <a:endParaRPr lang="en-US"/>
+          </a:p>
+        </p:txBody>
+      </p:sp>
     </p:spTree>
   </p:cSld>
   <p:clrMapOvr>

</xml_diff>

<commit_message>
feat(pptx): add layout-inheriting text placeholders (#113)
* feat(pptx): add layout-inheriting text placeholders

* fix(pptx): reject missing or non-finite element positions

* test(pptx): regenerate e2e fixtures for starter layout placeholders

The generators build decks through PresentationBuilder, whose starter layouts now declare standard placeholders, so every generated deck's slide layouts change. Only ppt/slideLayouts/slideLayoutN.xml differs (360 parts across 36 decks); the Open XML SDK validator reports the same errors before and after.
</commit_message>
<xml_diff>
--- a/e2e/pptx/fixtures/arrow-text-regressions.pptx
+++ b/e2e/pptx/fixtures/arrow-text-regressions.pptx
@@ -46,6 +46,126 @@
           <a:chExt cx="0" cy="0"/>
         </a:xfrm>
       </p:grpSpPr>
+      <p:sp>
+        <p:nvSpPr>
+          <p:cNvPr id="2" name="CtrTitle Placeholder 1"/>
+          <p:cNvSpPr>
+            <a:spLocks noGrp="1"/>
+          </p:cNvSpPr>
+          <p:nvPr>
+            <p:ph type="ctrTitle" idx="0"/>
+          </p:nvPr>
+        </p:nvSpPr>
+        <p:spPr>
+          <a:xfrm>
+            <a:off x="975360" y="1645920"/>
+            <a:ext cx="10241280" cy="1508760"/>
+          </a:xfrm>
+        </p:spPr>
+        <p:txBody>
+          <a:bodyPr/>
+          <a:lstStyle/>
+          <a:p>
+            <a:endParaRPr lang="en-US"/>
+          </a:p>
+        </p:txBody>
+      </p:sp>
+      <p:sp>
+        <p:nvSpPr>
+          <p:cNvPr id="3" name="SubTitle Placeholder 2"/>
+          <p:cNvSpPr>
+            <a:spLocks noGrp="1"/>
+          </p:cNvSpPr>
+          <p:nvPr>
+            <p:ph type="subTitle" idx="1"/>
+          </p:nvPr>
+        </p:nvSpPr>
+        <p:spPr>
+          <a:xfrm>
+            <a:off x="1463040" y="3360420"/>
+            <a:ext cx="9265920" cy="1371600"/>
+          </a:xfrm>
+        </p:spPr>
+        <p:txBody>
+          <a:bodyPr/>
+          <a:lstStyle/>
+          <a:p>
+            <a:endParaRPr lang="en-US"/>
+          </a:p>
+        </p:txBody>
+      </p:sp>
+      <p:sp>
+        <p:nvSpPr>
+          <p:cNvPr id="4" name="Dt Placeholder 3"/>
+          <p:cNvSpPr>
+            <a:spLocks noGrp="1"/>
+          </p:cNvSpPr>
+          <p:nvPr>
+            <p:ph type="dt" idx="10"/>
+          </p:nvPr>
+        </p:nvSpPr>
+        <p:spPr>
+          <a:xfrm>
+            <a:off x="609600" y="6309360"/>
+            <a:ext cx="3048000" cy="274320"/>
+          </a:xfrm>
+        </p:spPr>
+        <p:txBody>
+          <a:bodyPr/>
+          <a:lstStyle/>
+          <a:p>
+            <a:endParaRPr lang="en-US"/>
+          </a:p>
+        </p:txBody>
+      </p:sp>
+      <p:sp>
+        <p:nvSpPr>
+          <p:cNvPr id="5" name="Ftr Placeholder 4"/>
+          <p:cNvSpPr>
+            <a:spLocks noGrp="1"/>
+          </p:cNvSpPr>
+          <p:nvPr>
+            <p:ph type="ftr" idx="11"/>
+          </p:nvPr>
+        </p:nvSpPr>
+        <p:spPr>
+          <a:xfrm>
+            <a:off x="4023360" y="6309360"/>
+            <a:ext cx="4145280" cy="274320"/>
+          </a:xfrm>
+        </p:spPr>
+        <p:txBody>
+          <a:bodyPr/>
+          <a:lstStyle/>
+          <a:p>
+            <a:endParaRPr lang="en-US"/>
+          </a:p>
+        </p:txBody>
+      </p:sp>
+      <p:sp>
+        <p:nvSpPr>
+          <p:cNvPr id="6" name="SldNum Placeholder 5"/>
+          <p:cNvSpPr>
+            <a:spLocks noGrp="1"/>
+          </p:cNvSpPr>
+          <p:nvPr>
+            <p:ph type="sldNum" idx="12"/>
+          </p:nvPr>
+        </p:nvSpPr>
+        <p:spPr>
+          <a:xfrm>
+            <a:off x="9144000" y="6309360"/>
+            <a:ext cx="2438400" cy="274320"/>
+          </a:xfrm>
+        </p:spPr>
+        <p:txBody>
+          <a:bodyPr/>
+          <a:lstStyle/>
+          <a:p>
+            <a:endParaRPr lang="en-US"/>
+          </a:p>
+        </p:txBody>
+      </p:sp>
     </p:spTree>
   </p:cSld>
   <p:clrMapOvr>
@@ -71,6 +191,126 @@
           <a:chExt cx="0" cy="0"/>
         </a:xfrm>
       </p:grpSpPr>
+      <p:sp>
+        <p:nvSpPr>
+          <p:cNvPr id="2" name="Title Placeholder 1"/>
+          <p:cNvSpPr>
+            <a:spLocks noGrp="1"/>
+          </p:cNvSpPr>
+          <p:nvPr>
+            <p:ph type="title" idx="0"/>
+          </p:nvPr>
+        </p:nvSpPr>
+        <p:spPr>
+          <a:xfrm>
+            <a:off x="609600" y="274320"/>
+            <a:ext cx="10972800" cy="1028700"/>
+          </a:xfrm>
+        </p:spPr>
+        <p:txBody>
+          <a:bodyPr/>
+          <a:lstStyle/>
+          <a:p>
+            <a:endParaRPr lang="en-US"/>
+          </a:p>
+        </p:txBody>
+      </p:sp>
+      <p:sp>
+        <p:nvSpPr>
+          <p:cNvPr id="3" name="Obj Placeholder 2"/>
+          <p:cNvSpPr>
+            <a:spLocks noGrp="1"/>
+          </p:cNvSpPr>
+          <p:nvPr>
+            <p:ph type="obj" idx="1"/>
+          </p:nvPr>
+        </p:nvSpPr>
+        <p:spPr>
+          <a:xfrm>
+            <a:off x="609600" y="1577340"/>
+            <a:ext cx="10972800" cy="4389120"/>
+          </a:xfrm>
+        </p:spPr>
+        <p:txBody>
+          <a:bodyPr/>
+          <a:lstStyle/>
+          <a:p>
+            <a:endParaRPr lang="en-US"/>
+          </a:p>
+        </p:txBody>
+      </p:sp>
+      <p:sp>
+        <p:nvSpPr>
+          <p:cNvPr id="4" name="Dt Placeholder 3"/>
+          <p:cNvSpPr>
+            <a:spLocks noGrp="1"/>
+          </p:cNvSpPr>
+          <p:nvPr>
+            <p:ph type="dt" idx="10"/>
+          </p:nvPr>
+        </p:nvSpPr>
+        <p:spPr>
+          <a:xfrm>
+            <a:off x="609600" y="6309360"/>
+            <a:ext cx="3048000" cy="274320"/>
+          </a:xfrm>
+        </p:spPr>
+        <p:txBody>
+          <a:bodyPr/>
+          <a:lstStyle/>
+          <a:p>
+            <a:endParaRPr lang="en-US"/>
+          </a:p>
+        </p:txBody>
+      </p:sp>
+      <p:sp>
+        <p:nvSpPr>
+          <p:cNvPr id="5" name="Ftr Placeholder 4"/>
+          <p:cNvSpPr>
+            <a:spLocks noGrp="1"/>
+          </p:cNvSpPr>
+          <p:nvPr>
+            <p:ph type="ftr" idx="11"/>
+          </p:nvPr>
+        </p:nvSpPr>
+        <p:spPr>
+          <a:xfrm>
+            <a:off x="4023360" y="6309360"/>
+            <a:ext cx="4145280" cy="274320"/>
+          </a:xfrm>
+        </p:spPr>
+        <p:txBody>
+          <a:bodyPr/>
+          <a:lstStyle/>
+          <a:p>
+            <a:endParaRPr lang="en-US"/>
+          </a:p>
+        </p:txBody>
+      </p:sp>
+      <p:sp>
+        <p:nvSpPr>
+          <p:cNvPr id="6" name="SldNum Placeholder 5"/>
+          <p:cNvSpPr>
+            <a:spLocks noGrp="1"/>
+          </p:cNvSpPr>
+          <p:nvPr>
+            <p:ph type="sldNum" idx="12"/>
+          </p:nvPr>
+        </p:nvSpPr>
+        <p:spPr>
+          <a:xfrm>
+            <a:off x="9144000" y="6309360"/>
+            <a:ext cx="2438400" cy="274320"/>
+          </a:xfrm>
+        </p:spPr>
+        <p:txBody>
+          <a:bodyPr/>
+          <a:lstStyle/>
+          <a:p>
+            <a:endParaRPr lang="en-US"/>
+          </a:p>
+        </p:txBody>
+      </p:sp>
     </p:spTree>
   </p:cSld>
   <p:clrMapOvr>
@@ -96,6 +336,126 @@
           <a:chExt cx="0" cy="0"/>
         </a:xfrm>
       </p:grpSpPr>
+      <p:sp>
+        <p:nvSpPr>
+          <p:cNvPr id="2" name="Title Placeholder 1"/>
+          <p:cNvSpPr>
+            <a:spLocks noGrp="1"/>
+          </p:cNvSpPr>
+          <p:nvPr>
+            <p:ph type="title" idx="0"/>
+          </p:nvPr>
+        </p:nvSpPr>
+        <p:spPr>
+          <a:xfrm>
+            <a:off x="609600" y="274320"/>
+            <a:ext cx="10972800" cy="1028700"/>
+          </a:xfrm>
+        </p:spPr>
+        <p:txBody>
+          <a:bodyPr/>
+          <a:lstStyle/>
+          <a:p>
+            <a:endParaRPr lang="en-US"/>
+          </a:p>
+        </p:txBody>
+      </p:sp>
+      <p:sp>
+        <p:nvSpPr>
+          <p:cNvPr id="3" name="Obj Placeholder 2"/>
+          <p:cNvSpPr>
+            <a:spLocks noGrp="1"/>
+          </p:cNvSpPr>
+          <p:nvPr>
+            <p:ph type="obj" idx="1"/>
+          </p:nvPr>
+        </p:nvSpPr>
+        <p:spPr>
+          <a:xfrm>
+            <a:off x="609600" y="1577340"/>
+            <a:ext cx="10972800" cy="4389120"/>
+          </a:xfrm>
+        </p:spPr>
+        <p:txBody>
+          <a:bodyPr/>
+          <a:lstStyle/>
+          <a:p>
+            <a:endParaRPr lang="en-US"/>
+          </a:p>
+        </p:txBody>
+      </p:sp>
+      <p:sp>
+        <p:nvSpPr>
+          <p:cNvPr id="4" name="Dt Placeholder 3"/>
+          <p:cNvSpPr>
+            <a:spLocks noGrp="1"/>
+          </p:cNvSpPr>
+          <p:nvPr>
+            <p:ph type="dt" idx="10"/>
+          </p:nvPr>
+        </p:nvSpPr>
+        <p:spPr>
+          <a:xfrm>
+            <a:off x="609600" y="6309360"/>
+            <a:ext cx="3048000" cy="274320"/>
+          </a:xfrm>
+        </p:spPr>
+        <p:txBody>
+          <a:bodyPr/>
+          <a:lstStyle/>
+          <a:p>
+            <a:endParaRPr lang="en-US"/>
+          </a:p>
+        </p:txBody>
+      </p:sp>
+      <p:sp>
+        <p:nvSpPr>
+          <p:cNvPr id="5" name="Ftr Placeholder 4"/>
+          <p:cNvSpPr>
+            <a:spLocks noGrp="1"/>
+          </p:cNvSpPr>
+          <p:nvPr>
+            <p:ph type="ftr" idx="11"/>
+          </p:nvPr>
+        </p:nvSpPr>
+        <p:spPr>
+          <a:xfrm>
+            <a:off x="4023360" y="6309360"/>
+            <a:ext cx="4145280" cy="274320"/>
+          </a:xfrm>
+        </p:spPr>
+        <p:txBody>
+          <a:bodyPr/>
+          <a:lstStyle/>
+          <a:p>
+            <a:endParaRPr lang="en-US"/>
+          </a:p>
+        </p:txBody>
+      </p:sp>
+      <p:sp>
+        <p:nvSpPr>
+          <p:cNvPr id="6" name="SldNum Placeholder 5"/>
+          <p:cNvSpPr>
+            <a:spLocks noGrp="1"/>
+          </p:cNvSpPr>
+          <p:nvPr>
+            <p:ph type="sldNum" idx="12"/>
+          </p:nvPr>
+        </p:nvSpPr>
+        <p:spPr>
+          <a:xfrm>
+            <a:off x="9144000" y="6309360"/>
+            <a:ext cx="2438400" cy="274320"/>
+          </a:xfrm>
+        </p:spPr>
+        <p:txBody>
+          <a:bodyPr/>
+          <a:lstStyle/>
+          <a:p>
+            <a:endParaRPr lang="en-US"/>
+          </a:p>
+        </p:txBody>
+      </p:sp>
     </p:spTree>
   </p:cSld>
   <p:clrMapOvr>
@@ -121,6 +481,126 @@
           <a:chExt cx="0" cy="0"/>
         </a:xfrm>
       </p:grpSpPr>
+      <p:sp>
+        <p:nvSpPr>
+          <p:cNvPr id="2" name="Title Placeholder 1"/>
+          <p:cNvSpPr>
+            <a:spLocks noGrp="1"/>
+          </p:cNvSpPr>
+          <p:nvPr>
+            <p:ph type="title" idx="0"/>
+          </p:nvPr>
+        </p:nvSpPr>
+        <p:spPr>
+          <a:xfrm>
+            <a:off x="609600" y="274320"/>
+            <a:ext cx="10972800" cy="1028700"/>
+          </a:xfrm>
+        </p:spPr>
+        <p:txBody>
+          <a:bodyPr/>
+          <a:lstStyle/>
+          <a:p>
+            <a:endParaRPr lang="en-US"/>
+          </a:p>
+        </p:txBody>
+      </p:sp>
+      <p:sp>
+        <p:nvSpPr>
+          <p:cNvPr id="3" name="Obj Placeholder 2"/>
+          <p:cNvSpPr>
+            <a:spLocks noGrp="1"/>
+          </p:cNvSpPr>
+          <p:nvPr>
+            <p:ph type="obj" idx="1"/>
+          </p:nvPr>
+        </p:nvSpPr>
+        <p:spPr>
+          <a:xfrm>
+            <a:off x="609600" y="1577340"/>
+            <a:ext cx="10972800" cy="4389120"/>
+          </a:xfrm>
+        </p:spPr>
+        <p:txBody>
+          <a:bodyPr/>
+          <a:lstStyle/>
+          <a:p>
+            <a:endParaRPr lang="en-US"/>
+          </a:p>
+        </p:txBody>
+      </p:sp>
+      <p:sp>
+        <p:nvSpPr>
+          <p:cNvPr id="4" name="Dt Placeholder 3"/>
+          <p:cNvSpPr>
+            <a:spLocks noGrp="1"/>
+          </p:cNvSpPr>
+          <p:nvPr>
+            <p:ph type="dt" idx="10"/>
+          </p:nvPr>
+        </p:nvSpPr>
+        <p:spPr>
+          <a:xfrm>
+            <a:off x="609600" y="6309360"/>
+            <a:ext cx="3048000" cy="274320"/>
+          </a:xfrm>
+        </p:spPr>
+        <p:txBody>
+          <a:bodyPr/>
+          <a:lstStyle/>
+          <a:p>
+            <a:endParaRPr lang="en-US"/>
+          </a:p>
+        </p:txBody>
+      </p:sp>
+      <p:sp>
+        <p:nvSpPr>
+          <p:cNvPr id="5" name="Ftr Placeholder 4"/>
+          <p:cNvSpPr>
+            <a:spLocks noGrp="1"/>
+          </p:cNvSpPr>
+          <p:nvPr>
+            <p:ph type="ftr" idx="11"/>
+          </p:nvPr>
+        </p:nvSpPr>
+        <p:spPr>
+          <a:xfrm>
+            <a:off x="4023360" y="6309360"/>
+            <a:ext cx="4145280" cy="274320"/>
+          </a:xfrm>
+        </p:spPr>
+        <p:txBody>
+          <a:bodyPr/>
+          <a:lstStyle/>
+          <a:p>
+            <a:endParaRPr lang="en-US"/>
+          </a:p>
+        </p:txBody>
+      </p:sp>
+      <p:sp>
+        <p:nvSpPr>
+          <p:cNvPr id="6" name="SldNum Placeholder 5"/>
+          <p:cNvSpPr>
+            <a:spLocks noGrp="1"/>
+          </p:cNvSpPr>
+          <p:nvPr>
+            <p:ph type="sldNum" idx="12"/>
+          </p:nvPr>
+        </p:nvSpPr>
+        <p:spPr>
+          <a:xfrm>
+            <a:off x="9144000" y="6309360"/>
+            <a:ext cx="2438400" cy="274320"/>
+          </a:xfrm>
+        </p:spPr>
+        <p:txBody>
+          <a:bodyPr/>
+          <a:lstStyle/>
+          <a:p>
+            <a:endParaRPr lang="en-US"/>
+          </a:p>
+        </p:txBody>
+      </p:sp>
     </p:spTree>
   </p:cSld>
   <p:clrMapOvr>
@@ -146,6 +626,126 @@
           <a:chExt cx="0" cy="0"/>
         </a:xfrm>
       </p:grpSpPr>
+      <p:sp>
+        <p:nvSpPr>
+          <p:cNvPr id="2" name="Title Placeholder 1"/>
+          <p:cNvSpPr>
+            <a:spLocks noGrp="1"/>
+          </p:cNvSpPr>
+          <p:nvPr>
+            <p:ph type="title" idx="0"/>
+          </p:nvPr>
+        </p:nvSpPr>
+        <p:spPr>
+          <a:xfrm>
+            <a:off x="609600" y="2537460"/>
+            <a:ext cx="10972800" cy="1371600"/>
+          </a:xfrm>
+        </p:spPr>
+        <p:txBody>
+          <a:bodyPr/>
+          <a:lstStyle/>
+          <a:p>
+            <a:endParaRPr lang="en-US"/>
+          </a:p>
+        </p:txBody>
+      </p:sp>
+      <p:sp>
+        <p:nvSpPr>
+          <p:cNvPr id="3" name="Body Placeholder 2"/>
+          <p:cNvSpPr>
+            <a:spLocks noGrp="1"/>
+          </p:cNvSpPr>
+          <p:nvPr>
+            <p:ph type="body" idx="1"/>
+          </p:nvPr>
+        </p:nvSpPr>
+        <p:spPr>
+          <a:xfrm>
+            <a:off x="609600" y="4114800"/>
+            <a:ext cx="10972800" cy="1577340"/>
+          </a:xfrm>
+        </p:spPr>
+        <p:txBody>
+          <a:bodyPr/>
+          <a:lstStyle/>
+          <a:p>
+            <a:endParaRPr lang="en-US"/>
+          </a:p>
+        </p:txBody>
+      </p:sp>
+      <p:sp>
+        <p:nvSpPr>
+          <p:cNvPr id="4" name="Dt Placeholder 3"/>
+          <p:cNvSpPr>
+            <a:spLocks noGrp="1"/>
+          </p:cNvSpPr>
+          <p:nvPr>
+            <p:ph type="dt" idx="10"/>
+          </p:nvPr>
+        </p:nvSpPr>
+        <p:spPr>
+          <a:xfrm>
+            <a:off x="609600" y="6309360"/>
+            <a:ext cx="3048000" cy="274320"/>
+          </a:xfrm>
+        </p:spPr>
+        <p:txBody>
+          <a:bodyPr/>
+          <a:lstStyle/>
+          <a:p>
+            <a:endParaRPr lang="en-US"/>
+          </a:p>
+        </p:txBody>
+      </p:sp>
+      <p:sp>
+        <p:nvSpPr>
+          <p:cNvPr id="5" name="Ftr Placeholder 4"/>
+          <p:cNvSpPr>
+            <a:spLocks noGrp="1"/>
+          </p:cNvSpPr>
+          <p:nvPr>
+            <p:ph type="ftr" idx="11"/>
+          </p:nvPr>
+        </p:nvSpPr>
+        <p:spPr>
+          <a:xfrm>
+            <a:off x="4023360" y="6309360"/>
+            <a:ext cx="4145280" cy="274320"/>
+          </a:xfrm>
+        </p:spPr>
+        <p:txBody>
+          <a:bodyPr/>
+          <a:lstStyle/>
+          <a:p>
+            <a:endParaRPr lang="en-US"/>
+          </a:p>
+        </p:txBody>
+      </p:sp>
+      <p:sp>
+        <p:nvSpPr>
+          <p:cNvPr id="6" name="SldNum Placeholder 5"/>
+          <p:cNvSpPr>
+            <a:spLocks noGrp="1"/>
+          </p:cNvSpPr>
+          <p:nvPr>
+            <p:ph type="sldNum" idx="12"/>
+          </p:nvPr>
+        </p:nvSpPr>
+        <p:spPr>
+          <a:xfrm>
+            <a:off x="9144000" y="6309360"/>
+            <a:ext cx="2438400" cy="274320"/>
+          </a:xfrm>
+        </p:spPr>
+        <p:txBody>
+          <a:bodyPr/>
+          <a:lstStyle/>
+          <a:p>
+            <a:endParaRPr lang="en-US"/>
+          </a:p>
+        </p:txBody>
+      </p:sp>
     </p:spTree>
   </p:cSld>
   <p:clrMapOvr>
@@ -171,6 +771,150 @@
           <a:chExt cx="0" cy="0"/>
         </a:xfrm>
       </p:grpSpPr>
+      <p:sp>
+        <p:nvSpPr>
+          <p:cNvPr id="2" name="Title Placeholder 1"/>
+          <p:cNvSpPr>
+            <a:spLocks noGrp="1"/>
+          </p:cNvSpPr>
+          <p:nvPr>
+            <p:ph type="title" idx="0"/>
+          </p:nvPr>
+        </p:nvSpPr>
+        <p:spPr>
+          <a:xfrm>
+            <a:off x="609600" y="274320"/>
+            <a:ext cx="10972800" cy="1028700"/>
+          </a:xfrm>
+        </p:spPr>
+        <p:txBody>
+          <a:bodyPr/>
+          <a:lstStyle/>
+          <a:p>
+            <a:endParaRPr lang="en-US"/>
+          </a:p>
+        </p:txBody>
+      </p:sp>
+      <p:sp>
+        <p:nvSpPr>
+          <p:cNvPr id="3" name="Obj Placeholder 2"/>
+          <p:cNvSpPr>
+            <a:spLocks noGrp="1"/>
+          </p:cNvSpPr>
+          <p:nvPr>
+            <p:ph type="obj" idx="1"/>
+          </p:nvPr>
+        </p:nvSpPr>
+        <p:spPr>
+          <a:xfrm>
+            <a:off x="609600" y="1851660"/>
+            <a:ext cx="5242560" cy="4114800"/>
+          </a:xfrm>
+        </p:spPr>
+        <p:txBody>
+          <a:bodyPr/>
+          <a:lstStyle/>
+          <a:p>
+            <a:endParaRPr lang="en-US"/>
+          </a:p>
+        </p:txBody>
+      </p:sp>
+      <p:sp>
+        <p:nvSpPr>
+          <p:cNvPr id="4" name="Obj Placeholder 3"/>
+          <p:cNvSpPr>
+            <a:spLocks noGrp="1"/>
+          </p:cNvSpPr>
+          <p:nvPr>
+            <p:ph type="obj" idx="2"/>
+          </p:nvPr>
+        </p:nvSpPr>
+        <p:spPr>
+          <a:xfrm>
+            <a:off x="6339840" y="1851660"/>
+            <a:ext cx="5242560" cy="4114800"/>
+          </a:xfrm>
+        </p:spPr>
+        <p:txBody>
+          <a:bodyPr/>
+          <a:lstStyle/>
+          <a:p>
+            <a:endParaRPr lang="en-US"/>
+          </a:p>
+        </p:txBody>
+      </p:sp>
+      <p:sp>
+        <p:nvSpPr>
+          <p:cNvPr id="5" name="Dt Placeholder 4"/>
+          <p:cNvSpPr>
+            <a:spLocks noGrp="1"/>
+          </p:cNvSpPr>
+          <p:nvPr>
+            <p:ph type="dt" idx="10"/>
+          </p:nvPr>
+        </p:nvSpPr>
+        <p:spPr>
+          <a:xfrm>
+            <a:off x="609600" y="6309360"/>
+            <a:ext cx="3048000" cy="274320"/>
+          </a:xfrm>
+        </p:spPr>
+        <p:txBody>
+          <a:bodyPr/>
+          <a:lstStyle/>
+          <a:p>
+            <a:endParaRPr lang="en-US"/>
+          </a:p>
+        </p:txBody>
+      </p:sp>
+      <p:sp>
+        <p:nvSpPr>
+          <p:cNvPr id="6" name="Ftr Placeholder 5"/>
+          <p:cNvSpPr>
+            <a:spLocks noGrp="1"/>
+          </p:cNvSpPr>
+          <p:nvPr>
+            <p:ph type="ftr" idx="11"/>
+          </p:nvPr>
+        </p:nvSpPr>
+        <p:spPr>
+          <a:xfrm>
+            <a:off x="4023360" y="6309360"/>
+            <a:ext cx="4145280" cy="274320"/>
+          </a:xfrm>
+        </p:spPr>
+        <p:txBody>
+          <a:bodyPr/>
+          <a:lstStyle/>
+          <a:p>
+            <a:endParaRPr lang="en-US"/>
+          </a:p>
+        </p:txBody>
+      </p:sp>
+      <p:sp>
+        <p:nvSpPr>
+          <p:cNvPr id="7" name="SldNum Placeholder 6"/>
+          <p:cNvSpPr>
+            <a:spLocks noGrp="1"/>
+          </p:cNvSpPr>
+          <p:nvPr>
+            <p:ph type="sldNum" idx="12"/>
+          </p:nvPr>
+        </p:nvSpPr>
+        <p:spPr>
+          <a:xfrm>
+            <a:off x="9144000" y="6309360"/>
+            <a:ext cx="2438400" cy="274320"/>
+          </a:xfrm>
+        </p:spPr>
+        <p:txBody>
+          <a:bodyPr/>
+          <a:lstStyle/>
+          <a:p>
+            <a:endParaRPr lang="en-US"/>
+          </a:p>
+        </p:txBody>
+      </p:sp>
     </p:spTree>
   </p:cSld>
   <p:clrMapOvr>
@@ -196,6 +940,198 @@
           <a:chExt cx="0" cy="0"/>
         </a:xfrm>
       </p:grpSpPr>
+      <p:sp>
+        <p:nvSpPr>
+          <p:cNvPr id="2" name="Title Placeholder 1"/>
+          <p:cNvSpPr>
+            <a:spLocks noGrp="1"/>
+          </p:cNvSpPr>
+          <p:nvPr>
+            <p:ph type="title" idx="0"/>
+          </p:nvPr>
+        </p:nvSpPr>
+        <p:spPr>
+          <a:xfrm>
+            <a:off x="609600" y="274320"/>
+            <a:ext cx="10972800" cy="1028700"/>
+          </a:xfrm>
+        </p:spPr>
+        <p:txBody>
+          <a:bodyPr/>
+          <a:lstStyle/>
+          <a:p>
+            <a:endParaRPr lang="en-US"/>
+          </a:p>
+        </p:txBody>
+      </p:sp>
+      <p:sp>
+        <p:nvSpPr>
+          <p:cNvPr id="3" name="Obj Placeholder 2"/>
+          <p:cNvSpPr>
+            <a:spLocks noGrp="1"/>
+          </p:cNvSpPr>
+          <p:nvPr>
+            <p:ph type="obj" idx="1"/>
+          </p:nvPr>
+        </p:nvSpPr>
+        <p:spPr>
+          <a:xfrm>
+            <a:off x="609600" y="1851660"/>
+            <a:ext cx="5242560" cy="4114800"/>
+          </a:xfrm>
+        </p:spPr>
+        <p:txBody>
+          <a:bodyPr/>
+          <a:lstStyle/>
+          <a:p>
+            <a:endParaRPr lang="en-US"/>
+          </a:p>
+        </p:txBody>
+      </p:sp>
+      <p:sp>
+        <p:nvSpPr>
+          <p:cNvPr id="4" name="Obj Placeholder 3"/>
+          <p:cNvSpPr>
+            <a:spLocks noGrp="1"/>
+          </p:cNvSpPr>
+          <p:nvPr>
+            <p:ph type="obj" idx="2"/>
+          </p:nvPr>
+        </p:nvSpPr>
+        <p:spPr>
+          <a:xfrm>
+            <a:off x="6339840" y="1851660"/>
+            <a:ext cx="5242560" cy="4114800"/>
+          </a:xfrm>
+        </p:spPr>
+        <p:txBody>
+          <a:bodyPr/>
+          <a:lstStyle/>
+          <a:p>
+            <a:endParaRPr lang="en-US"/>
+          </a:p>
+        </p:txBody>
+      </p:sp>
+      <p:sp>
+        <p:nvSpPr>
+          <p:cNvPr id="5" name="Body Placeholder 4"/>
+          <p:cNvSpPr>
+            <a:spLocks noGrp="1"/>
+          </p:cNvSpPr>
+          <p:nvPr>
+            <p:ph type="body" idx="3"/>
+          </p:nvPr>
+        </p:nvSpPr>
+        <p:spPr>
+          <a:xfrm>
+            <a:off x="609600" y="1371600"/>
+            <a:ext cx="5242560" cy="480060"/>
+          </a:xfrm>
+        </p:spPr>
+        <p:txBody>
+          <a:bodyPr/>
+          <a:lstStyle/>
+          <a:p>
+            <a:endParaRPr lang="en-US"/>
+          </a:p>
+        </p:txBody>
+      </p:sp>
+      <p:sp>
+        <p:nvSpPr>
+          <p:cNvPr id="6" name="Body Placeholder 5"/>
+          <p:cNvSpPr>
+            <a:spLocks noGrp="1"/>
+          </p:cNvSpPr>
+          <p:nvPr>
+            <p:ph type="body" idx="4"/>
+          </p:nvPr>
+        </p:nvSpPr>
+        <p:spPr>
+          <a:xfrm>
+            <a:off x="6339840" y="1371600"/>
+            <a:ext cx="5242560" cy="480060"/>
+          </a:xfrm>
+        </p:spPr>
+        <p:txBody>
+          <a:bodyPr/>
+          <a:lstStyle/>
+          <a:p>
+            <a:endParaRPr lang="en-US"/>
+          </a:p>
+        </p:txBody>
+      </p:sp>
+      <p:sp>
+        <p:nvSpPr>
+          <p:cNvPr id="7" name="Dt Placeholder 6"/>
+          <p:cNvSpPr>
+            <a:spLocks noGrp="1"/>
+          </p:cNvSpPr>
+          <p:nvPr>
+            <p:ph type="dt" idx="10"/>
+          </p:nvPr>
+        </p:nvSpPr>
+        <p:spPr>
+          <a:xfrm>
+            <a:off x="609600" y="6309360"/>
+            <a:ext cx="3048000" cy="274320"/>
+          </a:xfrm>
+        </p:spPr>
+        <p:txBody>
+          <a:bodyPr/>
+          <a:lstStyle/>
+          <a:p>
+            <a:endParaRPr lang="en-US"/>
+          </a:p>
+        </p:txBody>
+      </p:sp>
+      <p:sp>
+        <p:nvSpPr>
+          <p:cNvPr id="8" name="Ftr Placeholder 7"/>
+          <p:cNvSpPr>
+            <a:spLocks noGrp="1"/>
+          </p:cNvSpPr>
+          <p:nvPr>
+            <p:ph type="ftr" idx="11"/>
+          </p:nvPr>
+        </p:nvSpPr>
+        <p:spPr>
+          <a:xfrm>
+            <a:off x="4023360" y="6309360"/>
+            <a:ext cx="4145280" cy="274320"/>
+          </a:xfrm>
+        </p:spPr>
+        <p:txBody>
+          <a:bodyPr/>
+          <a:lstStyle/>
+          <a:p>
+            <a:endParaRPr lang="en-US"/>
+          </a:p>
+        </p:txBody>
+      </p:sp>
+      <p:sp>
+        <p:nvSpPr>
+          <p:cNvPr id="9" name="SldNum Placeholder 8"/>
+          <p:cNvSpPr>
+            <a:spLocks noGrp="1"/>
+          </p:cNvSpPr>
+          <p:nvPr>
+            <p:ph type="sldNum" idx="12"/>
+          </p:nvPr>
+        </p:nvSpPr>
+        <p:spPr>
+          <a:xfrm>
+            <a:off x="9144000" y="6309360"/>
+            <a:ext cx="2438400" cy="274320"/>
+          </a:xfrm>
+        </p:spPr>
+        <p:txBody>
+          <a:bodyPr/>
+          <a:lstStyle/>
+          <a:p>
+            <a:endParaRPr lang="en-US"/>
+          </a:p>
+        </p:txBody>
+      </p:sp>
     </p:spTree>
   </p:cSld>
   <p:clrMapOvr>
@@ -221,6 +1157,102 @@
           <a:chExt cx="0" cy="0"/>
         </a:xfrm>
       </p:grpSpPr>
+      <p:sp>
+        <p:nvSpPr>
+          <p:cNvPr id="2" name="Title Placeholder 1"/>
+          <p:cNvSpPr>
+            <a:spLocks noGrp="1"/>
+          </p:cNvSpPr>
+          <p:nvPr>
+            <p:ph type="title" idx="0"/>
+          </p:nvPr>
+        </p:nvSpPr>
+        <p:spPr>
+          <a:xfrm>
+            <a:off x="609600" y="274320"/>
+            <a:ext cx="10972800" cy="1028700"/>
+          </a:xfrm>
+        </p:spPr>
+        <p:txBody>
+          <a:bodyPr/>
+          <a:lstStyle/>
+          <a:p>
+            <a:endParaRPr lang="en-US"/>
+          </a:p>
+        </p:txBody>
+      </p:sp>
+      <p:sp>
+        <p:nvSpPr>
+          <p:cNvPr id="3" name="Dt Placeholder 2"/>
+          <p:cNvSpPr>
+            <a:spLocks noGrp="1"/>
+          </p:cNvSpPr>
+          <p:nvPr>
+            <p:ph type="dt" idx="10"/>
+          </p:nvPr>
+        </p:nvSpPr>
+        <p:spPr>
+          <a:xfrm>
+            <a:off x="609600" y="6309360"/>
+            <a:ext cx="3048000" cy="274320"/>
+          </a:xfrm>
+        </p:spPr>
+        <p:txBody>
+          <a:bodyPr/>
+          <a:lstStyle/>
+          <a:p>
+            <a:endParaRPr lang="en-US"/>
+          </a:p>
+        </p:txBody>
+      </p:sp>
+      <p:sp>
+        <p:nvSpPr>
+          <p:cNvPr id="4" name="Ftr Placeholder 3"/>
+          <p:cNvSpPr>
+            <a:spLocks noGrp="1"/>
+          </p:cNvSpPr>
+          <p:nvPr>
+            <p:ph type="ftr" idx="11"/>
+          </p:nvPr>
+        </p:nvSpPr>
+        <p:spPr>
+          <a:xfrm>
+            <a:off x="4023360" y="6309360"/>
+            <a:ext cx="4145280" cy="274320"/>
+          </a:xfrm>
+        </p:spPr>
+        <p:txBody>
+          <a:bodyPr/>
+          <a:lstStyle/>
+          <a:p>
+            <a:endParaRPr lang="en-US"/>
+          </a:p>
+        </p:txBody>
+      </p:sp>
+      <p:sp>
+        <p:nvSpPr>
+          <p:cNvPr id="5" name="SldNum Placeholder 4"/>
+          <p:cNvSpPr>
+            <a:spLocks noGrp="1"/>
+          </p:cNvSpPr>
+          <p:nvPr>
+            <p:ph type="sldNum" idx="12"/>
+          </p:nvPr>
+        </p:nvSpPr>
+        <p:spPr>
+          <a:xfrm>
+            <a:off x="9144000" y="6309360"/>
+            <a:ext cx="2438400" cy="274320"/>
+          </a:xfrm>
+        </p:spPr>
+        <p:txBody>
+          <a:bodyPr/>
+          <a:lstStyle/>
+          <a:p>
+            <a:endParaRPr lang="en-US"/>
+          </a:p>
+        </p:txBody>
+      </p:sp>
     </p:spTree>
   </p:cSld>
   <p:clrMapOvr>
@@ -271,6 +1303,150 @@
           <a:chExt cx="0" cy="0"/>
         </a:xfrm>
       </p:grpSpPr>
+      <p:sp>
+        <p:nvSpPr>
+          <p:cNvPr id="2" name="Title Placeholder 1"/>
+          <p:cNvSpPr>
+            <a:spLocks noGrp="1"/>
+          </p:cNvSpPr>
+          <p:nvPr>
+            <p:ph type="title" idx="0"/>
+          </p:nvPr>
+        </p:nvSpPr>
+        <p:spPr>
+          <a:xfrm>
+            <a:off x="609600" y="274320"/>
+            <a:ext cx="10972800" cy="1028700"/>
+          </a:xfrm>
+        </p:spPr>
+        <p:txBody>
+          <a:bodyPr/>
+          <a:lstStyle/>
+          <a:p>
+            <a:endParaRPr lang="en-US"/>
+          </a:p>
+        </p:txBody>
+      </p:sp>
+      <p:sp>
+        <p:nvSpPr>
+          <p:cNvPr id="3" name="Obj Placeholder 2"/>
+          <p:cNvSpPr>
+            <a:spLocks noGrp="1"/>
+          </p:cNvSpPr>
+          <p:nvPr>
+            <p:ph type="obj" idx="1"/>
+          </p:nvPr>
+        </p:nvSpPr>
+        <p:spPr>
+          <a:xfrm>
+            <a:off x="4389120" y="1577340"/>
+            <a:ext cx="7193280" cy="4389120"/>
+          </a:xfrm>
+        </p:spPr>
+        <p:txBody>
+          <a:bodyPr/>
+          <a:lstStyle/>
+          <a:p>
+            <a:endParaRPr lang="en-US"/>
+          </a:p>
+        </p:txBody>
+      </p:sp>
+      <p:sp>
+        <p:nvSpPr>
+          <p:cNvPr id="4" name="Body Placeholder 3"/>
+          <p:cNvSpPr>
+            <a:spLocks noGrp="1"/>
+          </p:cNvSpPr>
+          <p:nvPr>
+            <p:ph type="body" idx="2"/>
+          </p:nvPr>
+        </p:nvSpPr>
+        <p:spPr>
+          <a:xfrm>
+            <a:off x="609600" y="1577340"/>
+            <a:ext cx="3291840" cy="4389120"/>
+          </a:xfrm>
+        </p:spPr>
+        <p:txBody>
+          <a:bodyPr/>
+          <a:lstStyle/>
+          <a:p>
+            <a:endParaRPr lang="en-US"/>
+          </a:p>
+        </p:txBody>
+      </p:sp>
+      <p:sp>
+        <p:nvSpPr>
+          <p:cNvPr id="5" name="Dt Placeholder 4"/>
+          <p:cNvSpPr>
+            <a:spLocks noGrp="1"/>
+          </p:cNvSpPr>
+          <p:nvPr>
+            <p:ph type="dt" idx="10"/>
+          </p:nvPr>
+        </p:nvSpPr>
+        <p:spPr>
+          <a:xfrm>
+            <a:off x="609600" y="6309360"/>
+            <a:ext cx="3048000" cy="274320"/>
+          </a:xfrm>
+        </p:spPr>
+        <p:txBody>
+          <a:bodyPr/>
+          <a:lstStyle/>
+          <a:p>
+            <a:endParaRPr lang="en-US"/>
+          </a:p>
+        </p:txBody>
+      </p:sp>
+      <p:sp>
+        <p:nvSpPr>
+          <p:cNvPr id="6" name="Ftr Placeholder 5"/>
+          <p:cNvSpPr>
+            <a:spLocks noGrp="1"/>
+          </p:cNvSpPr>
+          <p:nvPr>
+            <p:ph type="ftr" idx="11"/>
+          </p:nvPr>
+        </p:nvSpPr>
+        <p:spPr>
+          <a:xfrm>
+            <a:off x="4023360" y="6309360"/>
+            <a:ext cx="4145280" cy="274320"/>
+          </a:xfrm>
+        </p:spPr>
+        <p:txBody>
+          <a:bodyPr/>
+          <a:lstStyle/>
+          <a:p>
+            <a:endParaRPr lang="en-US"/>
+          </a:p>
+        </p:txBody>
+      </p:sp>
+      <p:sp>
+        <p:nvSpPr>
+          <p:cNvPr id="7" name="SldNum Placeholder 6"/>
+          <p:cNvSpPr>
+            <a:spLocks noGrp="1"/>
+          </p:cNvSpPr>
+          <p:nvPr>
+            <p:ph type="sldNum" idx="12"/>
+          </p:nvPr>
+        </p:nvSpPr>
+        <p:spPr>
+          <a:xfrm>
+            <a:off x="9144000" y="6309360"/>
+            <a:ext cx="2438400" cy="274320"/>
+          </a:xfrm>
+        </p:spPr>
+        <p:txBody>
+          <a:bodyPr/>
+          <a:lstStyle/>
+          <a:p>
+            <a:endParaRPr lang="en-US"/>
+          </a:p>
+        </p:txBody>
+      </p:sp>
     </p:spTree>
   </p:cSld>
   <p:clrMapOvr>
@@ -296,6 +1472,150 @@
           <a:chExt cx="0" cy="0"/>
         </a:xfrm>
       </p:grpSpPr>
+      <p:sp>
+        <p:nvSpPr>
+          <p:cNvPr id="2" name="Title Placeholder 1"/>
+          <p:cNvSpPr>
+            <a:spLocks noGrp="1"/>
+          </p:cNvSpPr>
+          <p:nvPr>
+            <p:ph type="title" idx="0"/>
+          </p:nvPr>
+        </p:nvSpPr>
+        <p:spPr>
+          <a:xfrm>
+            <a:off x="609600" y="274320"/>
+            <a:ext cx="10972800" cy="1028700"/>
+          </a:xfrm>
+        </p:spPr>
+        <p:txBody>
+          <a:bodyPr/>
+          <a:lstStyle/>
+          <a:p>
+            <a:endParaRPr lang="en-US"/>
+          </a:p>
+        </p:txBody>
+      </p:sp>
+      <p:sp>
+        <p:nvSpPr>
+          <p:cNvPr id="3" name="Pic Placeholder 2"/>
+          <p:cNvSpPr>
+            <a:spLocks noGrp="1"/>
+          </p:cNvSpPr>
+          <p:nvPr>
+            <p:ph type="pic" idx="1"/>
+          </p:nvPr>
+        </p:nvSpPr>
+        <p:spPr>
+          <a:xfrm>
+            <a:off x="4389120" y="1577340"/>
+            <a:ext cx="7193280" cy="4389120"/>
+          </a:xfrm>
+        </p:spPr>
+        <p:txBody>
+          <a:bodyPr/>
+          <a:lstStyle/>
+          <a:p>
+            <a:endParaRPr lang="en-US"/>
+          </a:p>
+        </p:txBody>
+      </p:sp>
+      <p:sp>
+        <p:nvSpPr>
+          <p:cNvPr id="4" name="Body Placeholder 3"/>
+          <p:cNvSpPr>
+            <a:spLocks noGrp="1"/>
+          </p:cNvSpPr>
+          <p:nvPr>
+            <p:ph type="body" idx="2"/>
+          </p:nvPr>
+        </p:nvSpPr>
+        <p:spPr>
+          <a:xfrm>
+            <a:off x="609600" y="1577340"/>
+            <a:ext cx="3291840" cy="4389120"/>
+          </a:xfrm>
+        </p:spPr>
+        <p:txBody>
+          <a:bodyPr/>
+          <a:lstStyle/>
+          <a:p>
+            <a:endParaRPr lang="en-US"/>
+          </a:p>
+        </p:txBody>
+      </p:sp>
+      <p:sp>
+        <p:nvSpPr>
+          <p:cNvPr id="5" name="Dt Placeholder 4"/>
+          <p:cNvSpPr>
+            <a:spLocks noGrp="1"/>
+          </p:cNvSpPr>
+          <p:nvPr>
+            <p:ph type="dt" idx="10"/>
+          </p:nvPr>
+        </p:nvSpPr>
+        <p:spPr>
+          <a:xfrm>
+            <a:off x="609600" y="6309360"/>
+            <a:ext cx="3048000" cy="274320"/>
+          </a:xfrm>
+        </p:spPr>
+        <p:txBody>
+          <a:bodyPr/>
+          <a:lstStyle/>
+          <a:p>
+            <a:endParaRPr lang="en-US"/>
+          </a:p>
+        </p:txBody>
+      </p:sp>
+      <p:sp>
+        <p:nvSpPr>
+          <p:cNvPr id="6" name="Ftr Placeholder 5"/>
+          <p:cNvSpPr>
+            <a:spLocks noGrp="1"/>
+          </p:cNvSpPr>
+          <p:nvPr>
+            <p:ph type="ftr" idx="11"/>
+          </p:nvPr>
+        </p:nvSpPr>
+        <p:spPr>
+          <a:xfrm>
+            <a:off x="4023360" y="6309360"/>
+            <a:ext cx="4145280" cy="274320"/>
+          </a:xfrm>
+        </p:spPr>
+        <p:txBody>
+          <a:bodyPr/>
+          <a:lstStyle/>
+          <a:p>
+            <a:endParaRPr lang="en-US"/>
+          </a:p>
+        </p:txBody>
+      </p:sp>
+      <p:sp>
+        <p:nvSpPr>
+          <p:cNvPr id="7" name="SldNum Placeholder 6"/>
+          <p:cNvSpPr>
+            <a:spLocks noGrp="1"/>
+          </p:cNvSpPr>
+          <p:nvPr>
+            <p:ph type="sldNum" idx="12"/>
+          </p:nvPr>
+        </p:nvSpPr>
+        <p:spPr>
+          <a:xfrm>
+            <a:off x="9144000" y="6309360"/>
+            <a:ext cx="2438400" cy="274320"/>
+          </a:xfrm>
+        </p:spPr>
+        <p:txBody>
+          <a:bodyPr/>
+          <a:lstStyle/>
+          <a:p>
+            <a:endParaRPr lang="en-US"/>
+          </a:p>
+        </p:txBody>
+      </p:sp>
     </p:spTree>
   </p:cSld>
   <p:clrMapOvr>

</xml_diff>